<commit_message>
added module 4 demo campusHub master
</commit_message>
<xml_diff>
--- a/Unit 4/Tab_Navigation_Updated.pptx
+++ b/Unit 4/Tab_Navigation_Updated.pptx
@@ -227,7 +227,7 @@
           <a:p>
             <a:fld id="{AC356047-9B32-4B44-A900-2428BFBDDF8F}" type="datetimeFigureOut">
               <a:rPr lang="en-US" smtClean="0"/>
-              <a:t>9/15/2026</a:t>
+              <a:t>9/25/2026</a:t>
             </a:fld>
             <a:endParaRPr lang="en-US"/>
           </a:p>
@@ -2287,7 +2287,7 @@
           <a:p>
             <a:fld id="{5BCAD085-E8A6-8845-BD4E-CB4CCA059FC4}" type="datetimeFigureOut">
               <a:rPr lang="en-US" smtClean="0"/>
-              <a:t>9/15/2026</a:t>
+              <a:t>9/25/2026</a:t>
             </a:fld>
             <a:endParaRPr lang="en-US"/>
           </a:p>
@@ -2455,7 +2455,7 @@
           <a:p>
             <a:fld id="{5BCAD085-E8A6-8845-BD4E-CB4CCA059FC4}" type="datetimeFigureOut">
               <a:rPr lang="en-US" smtClean="0"/>
-              <a:t>9/15/2026</a:t>
+              <a:t>9/25/2026</a:t>
             </a:fld>
             <a:endParaRPr lang="en-US"/>
           </a:p>
@@ -2633,7 +2633,7 @@
           <a:p>
             <a:fld id="{5BCAD085-E8A6-8845-BD4E-CB4CCA059FC4}" type="datetimeFigureOut">
               <a:rPr lang="en-US" smtClean="0"/>
-              <a:t>9/15/2026</a:t>
+              <a:t>9/25/2026</a:t>
             </a:fld>
             <a:endParaRPr lang="en-US"/>
           </a:p>
@@ -2801,7 +2801,7 @@
           <a:p>
             <a:fld id="{5BCAD085-E8A6-8845-BD4E-CB4CCA059FC4}" type="datetimeFigureOut">
               <a:rPr lang="en-US" smtClean="0"/>
-              <a:t>9/15/2026</a:t>
+              <a:t>9/25/2026</a:t>
             </a:fld>
             <a:endParaRPr lang="en-US"/>
           </a:p>
@@ -3046,7 +3046,7 @@
           <a:p>
             <a:fld id="{5BCAD085-E8A6-8845-BD4E-CB4CCA059FC4}" type="datetimeFigureOut">
               <a:rPr lang="en-US" smtClean="0"/>
-              <a:t>9/15/2026</a:t>
+              <a:t>9/25/2026</a:t>
             </a:fld>
             <a:endParaRPr lang="en-US"/>
           </a:p>
@@ -3331,7 +3331,7 @@
           <a:p>
             <a:fld id="{5BCAD085-E8A6-8845-BD4E-CB4CCA059FC4}" type="datetimeFigureOut">
               <a:rPr lang="en-US" smtClean="0"/>
-              <a:t>9/15/2026</a:t>
+              <a:t>9/25/2026</a:t>
             </a:fld>
             <a:endParaRPr lang="en-US"/>
           </a:p>
@@ -3750,7 +3750,7 @@
           <a:p>
             <a:fld id="{5BCAD085-E8A6-8845-BD4E-CB4CCA059FC4}" type="datetimeFigureOut">
               <a:rPr lang="en-US" smtClean="0"/>
-              <a:t>9/15/2026</a:t>
+              <a:t>9/25/2026</a:t>
             </a:fld>
             <a:endParaRPr lang="en-US"/>
           </a:p>
@@ -3867,7 +3867,7 @@
           <a:p>
             <a:fld id="{5BCAD085-E8A6-8845-BD4E-CB4CCA059FC4}" type="datetimeFigureOut">
               <a:rPr lang="en-US" smtClean="0"/>
-              <a:t>9/15/2026</a:t>
+              <a:t>9/25/2026</a:t>
             </a:fld>
             <a:endParaRPr lang="en-US"/>
           </a:p>
@@ -3962,7 +3962,7 @@
           <a:p>
             <a:fld id="{5BCAD085-E8A6-8845-BD4E-CB4CCA059FC4}" type="datetimeFigureOut">
               <a:rPr lang="en-US" smtClean="0"/>
-              <a:t>9/15/2026</a:t>
+              <a:t>9/25/2026</a:t>
             </a:fld>
             <a:endParaRPr lang="en-US"/>
           </a:p>
@@ -4237,7 +4237,7 @@
           <a:p>
             <a:fld id="{5BCAD085-E8A6-8845-BD4E-CB4CCA059FC4}" type="datetimeFigureOut">
               <a:rPr lang="en-US" smtClean="0"/>
-              <a:t>9/15/2026</a:t>
+              <a:t>9/25/2026</a:t>
             </a:fld>
             <a:endParaRPr lang="en-US"/>
           </a:p>
@@ -4489,7 +4489,7 @@
           <a:p>
             <a:fld id="{5BCAD085-E8A6-8845-BD4E-CB4CCA059FC4}" type="datetimeFigureOut">
               <a:rPr lang="en-US" smtClean="0"/>
-              <a:t>9/15/2026</a:t>
+              <a:t>9/25/2026</a:t>
             </a:fld>
             <a:endParaRPr lang="en-US"/>
           </a:p>
@@ -4700,7 +4700,7 @@
           <a:p>
             <a:fld id="{5BCAD085-E8A6-8845-BD4E-CB4CCA059FC4}" type="datetimeFigureOut">
               <a:rPr lang="en-US" smtClean="0"/>
-              <a:t>9/15/2026</a:t>
+              <a:t>9/25/2026</a:t>
             </a:fld>
             <a:endParaRPr lang="en-US"/>
           </a:p>
@@ -19948,7 +19948,7 @@
                 </a:solidFill>
                 <a:latin typeface="Calibri"/>
               </a:rPr>
-              <a:t>Class Activity</a:t>
+              <a:t>Activity</a:t>
             </a:r>
           </a:p>
         </p:txBody>

</xml_diff>